<commit_message>
Tambah grid search, uji signifikansi, dan tab pola soft pity
- Hyperparameter keenam algoritma dipilih dengan GridSearchCV (GroupKFold
  4-fold) pada 100 akun simulasi tambahan yang tidak dipakai untuk evaluasi.
  Pada eksperimen data asli, grid search diulang di dalam setiap fold
  (nested cross-validation).
- Uji t berpasangan terkoreksi (Nadeau & Bengio, 2003) terhadap model
  berakurasi tertinggi, termasuk penanda bila beberapa model seri.
- Halaman Perbandingan Algoritma: tab "Pola soft pity", tabel uji
  signifikansi, hyperparameter hasil grid search, dan pengaruh grid search
  pada data asli.
- Proposal, laporan, dan slide kini membaca tabel serta angka hasil langsung
  dari models/report.json (rep.js); subbab teori baru 2.7, Bab IV disusun
  ulang (hasil grid search dan uji signifikansi), grafik dan tangkapan layar
  dibuat ulang.
- LAPORAN.md, README, dan tanya jawab di PANDUAN_PENGUMPULAN disesuaikan.
</commit_message>
<xml_diff>
--- a/docs/tugas/UTS_Slide_Kelompok6_A11.4502.pptx
+++ b/docs/tugas/UTS_Slide_Kelompok6_A11.4502.pptx
@@ -257,10 +257,10 @@
                   <c:v>91.1</c:v>
                 </c:pt>
                 <c:pt idx="2">
-                  <c:v>85.7</c:v>
+                  <c:v>89.2</c:v>
                 </c:pt>
                 <c:pt idx="3">
-                  <c:v>91.1</c:v>
+                  <c:v>91</c:v>
                 </c:pt>
                 <c:pt idx="4">
                   <c:v>88.9</c:v>
@@ -370,10 +370,10 @@
                   <c:v>93.5</c:v>
                 </c:pt>
                 <c:pt idx="2">
-                  <c:v>87.5</c:v>
+                  <c:v>91.1</c:v>
                 </c:pt>
                 <c:pt idx="3">
-                  <c:v>93.5</c:v>
+                  <c:v>93.1</c:v>
                 </c:pt>
                 <c:pt idx="4">
                   <c:v>91.1</c:v>
@@ -1395,7 +1395,7 @@
           <a:p>
             <a:r>
               <a:rPr lang="en-US" dirty="0"/>
-              <a:t>Skenario evaluasi (±1 menit). Pembagian data per akun mencegah kebocoran, karena pull yang berurutan saling berkaitan. Cross-validation lima fold untuk hasil yang stabil, lalu uji akhir di data asli. Poin keempat adalah eksperimen kedua: semua algoritma dilatih dan diuji hanya dengan data asli, 1.209 baris, dibagi per siklus pity menjadi 5 bagian, supaya hasil tidak bergantung pada data simulasi. Kami tidak memakai oversampling seperti SMOTE, karena yang dicari adalah angka peluang yang tepat; ketidakseimbangan ditangani lewat pilihan metrik.</a:t>
+              <a:t>Skenario evaluasi (±1 menit). Pembagian data per akun mencegah kebocoran, karena pull yang berurutan saling berkaitan. Cross-validation lima fold untuk hasil yang stabil, lalu uji akhir di data asli. Hyperparameter setiap algoritma dipilih dengan grid search memakai 100 akun simulasi tambahan yang tidak dipakai untuk evaluasi, jadi tidak ada kebocoran. Perbedaan antar-model diuji dengan uji t berpasangan terkoreksi, supaya kita tahu selisihnya nyata atau hanya kebetulan. Poin kelima adalah eksperimen kedua: semua algoritma dilatih dan diuji hanya dengan data asli, 1.209 baris, dibagi per siklus pity menjadi 5 bagian, dan grid search diulang di dalam setiap bagian. Kami tidak memakai oversampling seperti SMOTE, karena yang dicari adalah angka peluang yang tepat; ketidakseimbangan ditangani lewat pilihan metrik.</a:t>
             </a:r>
             <a:endParaRPr lang="en-US" dirty="0"/>
           </a:p>
@@ -1571,7 +1571,7 @@
           <a:p>
             <a:r>
               <a:rPr lang="en-US" dirty="0"/>
-              <a:t>Hasil awal (±2 menit). Prototipe sudah berjalan dan bisa dibuka di HP. Validasi: saat dicek, pity akun asli 70 dari 90 dan 46 dari 80 sama persis dengan di game. Hasil awal tugas B: model pohon dan KNN sekitar 91 persen di simulasi dan 93 persen di data asli, Logistic Regression dan Naive Bayes lebih rendah. Eksperimen latih dan uji dengan data asli saja, 1.209 baris, juga sudah dilakukan: Decision Tree tetap tertinggi sekitar 93 persen. Analisis awal data asli memperlihatkan laju S Agent hampir nol sampai pull ke-73 lalu melonjak mulai pull ke-74, sesuai estimasi soft pity. Hasil lengkap akan dibahas di laporan akhir.</a:t>
+              <a:t>Hasil awal (±2 menit). Prototipe sudah berjalan dan bisa dibuka di HP. Validasi: saat dicek, pity akun asli 70 dari 90 dan 46 dari 80 sama persis dengan di game. Hasil awal tugas B: model pohon dan KNN sekitar 91 persen di simulasi dan 93 persen di data asli, Logistic Regression dan Naive Bayes lebih rendah. Eksperimen latih dan uji dengan data asli saja, 1.209 baris, juga sudah dilakukan: Decision Tree tetap tertinggi sekitar 93 persen. Uji coba grid search membuat Naive Bayes dan KNN membaik, dan uji signifikansi awal menunjukkan selisih antaralgoritma di data asli yang masih sedikit belum bermakna. Analisis awal data asli memperlihatkan laju S Agent hampir nol sampai pull ke-73 lalu melonjak mulai pull ke-74, sesuai estimasi soft pity. Hasil lengkap akan dibahas di laporan akhir.</a:t>
             </a:r>
             <a:endParaRPr lang="en-US" dirty="0"/>
           </a:p>
@@ -2451,7 +2451,7 @@
           <a:p>
             <a:r>
               <a:rPr lang="en-US" dirty="0"/>
-              <a:t>Algoritma (±2 menit). Jelaskan singkat keenam algoritma. Naive Bayes, KNN, dan Decision Tree adalah materi kuliah. Logistic Regression sebagai model linear sederhana. Random Forest dan XGBoost adalah ensemble pohon. Ditambah dua pembanding: baseline yang selalu menebak tidak dapat S, dan Markov Chain sebagai acuan teori.</a:t>
+              <a:t>Algoritma (±2 menit). Jelaskan singkat keenam algoritma. Naive Bayes, KNN, dan Decision Tree adalah materi kuliah. Logistic Regression sebagai model linear sederhana. Random Forest dan XGBoost adalah ensemble pohon. Ditambah dua pembanding: baseline yang selalu menebak tidak dapat S, dan Markov Chain sebagai acuan teori. Tekankan bahwa pengaturan setiap algoritma, misalnya jumlah tetangga k pada KNN, tidak ditebak, tetapi dipilih dengan grid search.</a:t>
             </a:r>
             <a:endParaRPr lang="en-US" dirty="0"/>
           </a:p>
@@ -7649,12 +7649,12 @@
         </p:nvSpPr>
         <p:spPr>
           <a:xfrm>
-            <a:off x="548640" y="1828800"/>
-            <a:ext cx="2624328" cy="2926080"/>
+            <a:off x="548640" y="1737360"/>
+            <a:ext cx="2103120" cy="3108960"/>
           </a:xfrm>
           <a:prstGeom prst="roundRect">
             <a:avLst>
-              <a:gd name="adj" fmla="val 2787"/>
+              <a:gd name="adj" fmla="val 3478"/>
             </a:avLst>
           </a:prstGeom>
           <a:solidFill>
@@ -7676,7 +7676,7 @@
         </p:nvSpPr>
         <p:spPr>
           <a:xfrm>
-            <a:off x="777240" y="2057400"/>
+            <a:off x="777240" y="1965960"/>
             <a:ext cx="457200" cy="457200"/>
           </a:xfrm>
           <a:prstGeom prst="ellipse">
@@ -7696,7 +7696,7 @@
         </p:nvSpPr>
         <p:spPr>
           <a:xfrm>
-            <a:off x="777240" y="2057400"/>
+            <a:off x="777240" y="1965960"/>
             <a:ext cx="457200" cy="457200"/>
           </a:xfrm>
           <a:prstGeom prst="rect">
@@ -7735,8 +7735,8 @@
         </p:nvSpPr>
         <p:spPr>
           <a:xfrm>
-            <a:off x="777240" y="2651760"/>
-            <a:ext cx="2167128" cy="731520"/>
+            <a:off x="777240" y="2560320"/>
+            <a:ext cx="1645920" cy="731520"/>
           </a:xfrm>
           <a:prstGeom prst="rect">
             <a:avLst/>
@@ -7752,7 +7752,7 @@
               <a:buNone/>
             </a:pPr>
             <a:r>
-              <a:rPr lang="en-US" sz="1800" b="1" dirty="0">
+              <a:rPr lang="en-US" sz="1700" b="1" dirty="0">
                 <a:solidFill>
                   <a:srgbClr val="E6EDF3"/>
                 </a:solidFill>
@@ -7762,7 +7762,7 @@
               </a:rPr>
               <a:t>Split per akun</a:t>
             </a:r>
-            <a:endParaRPr lang="en-US" sz="1800" dirty="0"/>
+            <a:endParaRPr lang="en-US" sz="1700" dirty="0"/>
           </a:p>
         </p:txBody>
       </p:sp>
@@ -7774,8 +7774,8 @@
         </p:nvSpPr>
         <p:spPr>
           <a:xfrm>
-            <a:off x="777240" y="3429000"/>
-            <a:ext cx="2167128" cy="1143000"/>
+            <a:off x="777240" y="3337560"/>
+            <a:ext cx="1645920" cy="1325880"/>
           </a:xfrm>
           <a:prstGeom prst="rect">
             <a:avLst/>
@@ -7794,7 +7794,7 @@
               <a:buNone/>
             </a:pPr>
             <a:r>
-              <a:rPr lang="en-US" sz="1500" dirty="0">
+              <a:rPr lang="en-US" sz="1400" dirty="0">
                 <a:solidFill>
                   <a:srgbClr val="A9B4C2"/>
                 </a:solidFill>
@@ -7804,7 +7804,7 @@
               </a:rPr>
               <a:t>Pull dari satu akun tidak boleh ada di data latih dan uji sekaligus.</a:t>
             </a:r>
-            <a:endParaRPr lang="en-US" sz="1500" dirty="0"/>
+            <a:endParaRPr lang="en-US" sz="1400" dirty="0"/>
           </a:p>
         </p:txBody>
       </p:sp>
@@ -7816,12 +7816,12 @@
         </p:nvSpPr>
         <p:spPr>
           <a:xfrm>
-            <a:off x="3355848" y="1828800"/>
-            <a:ext cx="2624328" cy="2926080"/>
+            <a:off x="2798064" y="1737360"/>
+            <a:ext cx="2103120" cy="3108960"/>
           </a:xfrm>
           <a:prstGeom prst="roundRect">
             <a:avLst>
-              <a:gd name="adj" fmla="val 2787"/>
+              <a:gd name="adj" fmla="val 3478"/>
             </a:avLst>
           </a:prstGeom>
           <a:solidFill>
@@ -7843,14 +7843,14 @@
         </p:nvSpPr>
         <p:spPr>
           <a:xfrm>
-            <a:off x="3584448" y="2057400"/>
+            <a:off x="3026664" y="1965960"/>
             <a:ext cx="457200" cy="457200"/>
           </a:xfrm>
           <a:prstGeom prst="ellipse">
             <a:avLst/>
           </a:prstGeom>
           <a:solidFill>
-            <a:srgbClr val="58A6FF"/>
+            <a:srgbClr val="FF7EB6"/>
           </a:solidFill>
           <a:ln/>
         </p:spPr>
@@ -7863,7 +7863,7 @@
         </p:nvSpPr>
         <p:spPr>
           <a:xfrm>
-            <a:off x="3584448" y="2057400"/>
+            <a:off x="3026664" y="1965960"/>
             <a:ext cx="457200" cy="457200"/>
           </a:xfrm>
           <a:prstGeom prst="rect">
@@ -7902,8 +7902,8 @@
         </p:nvSpPr>
         <p:spPr>
           <a:xfrm>
-            <a:off x="3584448" y="2651760"/>
-            <a:ext cx="2167128" cy="731520"/>
+            <a:off x="3026664" y="2560320"/>
+            <a:ext cx="1645920" cy="731520"/>
           </a:xfrm>
           <a:prstGeom prst="rect">
             <a:avLst/>
@@ -7919,7 +7919,7 @@
               <a:buNone/>
             </a:pPr>
             <a:r>
-              <a:rPr lang="en-US" sz="1800" b="1" dirty="0">
+              <a:rPr lang="en-US" sz="1700" b="1" dirty="0">
                 <a:solidFill>
                   <a:srgbClr val="E6EDF3"/>
                 </a:solidFill>
@@ -7927,9 +7927,9 @@
                 <a:ea typeface="Cambria" pitchFamily="34" charset="-122"/>
                 <a:cs typeface="Cambria" pitchFamily="34" charset="-120"/>
               </a:rPr>
-              <a:t>5-fold GroupKFold</a:t>
-            </a:r>
-            <a:endParaRPr lang="en-US" sz="1800" dirty="0"/>
+              <a:t>Grid search</a:t>
+            </a:r>
+            <a:endParaRPr lang="en-US" sz="1700" dirty="0"/>
           </a:p>
         </p:txBody>
       </p:sp>
@@ -7941,8 +7941,8 @@
         </p:nvSpPr>
         <p:spPr>
           <a:xfrm>
-            <a:off x="3584448" y="3429000"/>
-            <a:ext cx="2167128" cy="1143000"/>
+            <a:off x="3026664" y="3337560"/>
+            <a:ext cx="1645920" cy="1325880"/>
           </a:xfrm>
           <a:prstGeom prst="rect">
             <a:avLst/>
@@ -7961,7 +7961,7 @@
               <a:buNone/>
             </a:pPr>
             <a:r>
-              <a:rPr lang="en-US" sz="1500" dirty="0">
+              <a:rPr lang="en-US" sz="1400" dirty="0">
                 <a:solidFill>
                   <a:srgbClr val="A9B4C2"/>
                 </a:solidFill>
@@ -7969,9 +7969,9 @@
                 <a:ea typeface="Calibri" pitchFamily="34" charset="-122"/>
                 <a:cs typeface="Calibri" pitchFamily="34" charset="-120"/>
               </a:rPr>
-              <a:t>Rata-rata ± simpangan baku dari 5 percobaan.</a:t>
-            </a:r>
-            <a:endParaRPr lang="en-US" sz="1500" dirty="0"/>
+              <a:t>Hyperparameter dipilih di 100 akun simulasi terpisah (tidak dipakai evaluasi).</a:t>
+            </a:r>
+            <a:endParaRPr lang="en-US" sz="1400" dirty="0"/>
           </a:p>
         </p:txBody>
       </p:sp>
@@ -7983,12 +7983,12 @@
         </p:nvSpPr>
         <p:spPr>
           <a:xfrm>
-            <a:off x="6163056" y="1828800"/>
-            <a:ext cx="2624328" cy="2926080"/>
+            <a:off x="5047488" y="1737360"/>
+            <a:ext cx="2103120" cy="3108960"/>
           </a:xfrm>
           <a:prstGeom prst="roundRect">
             <a:avLst>
-              <a:gd name="adj" fmla="val 2787"/>
+              <a:gd name="adj" fmla="val 3478"/>
             </a:avLst>
           </a:prstGeom>
           <a:solidFill>
@@ -8010,14 +8010,14 @@
         </p:nvSpPr>
         <p:spPr>
           <a:xfrm>
-            <a:off x="6391656" y="2057400"/>
+            <a:off x="5276088" y="1965960"/>
             <a:ext cx="457200" cy="457200"/>
           </a:xfrm>
           <a:prstGeom prst="ellipse">
             <a:avLst/>
           </a:prstGeom>
           <a:solidFill>
-            <a:srgbClr val="3FB950"/>
+            <a:srgbClr val="58A6FF"/>
           </a:solidFill>
           <a:ln/>
         </p:spPr>
@@ -8030,7 +8030,7 @@
         </p:nvSpPr>
         <p:spPr>
           <a:xfrm>
-            <a:off x="6391656" y="2057400"/>
+            <a:off x="5276088" y="1965960"/>
             <a:ext cx="457200" cy="457200"/>
           </a:xfrm>
           <a:prstGeom prst="rect">
@@ -8069,8 +8069,8 @@
         </p:nvSpPr>
         <p:spPr>
           <a:xfrm>
-            <a:off x="6391656" y="2651760"/>
-            <a:ext cx="2167128" cy="731520"/>
+            <a:off x="5276088" y="2560320"/>
+            <a:ext cx="1645920" cy="731520"/>
           </a:xfrm>
           <a:prstGeom prst="rect">
             <a:avLst/>
@@ -8086,7 +8086,7 @@
               <a:buNone/>
             </a:pPr>
             <a:r>
-              <a:rPr lang="en-US" sz="1800" b="1" dirty="0">
+              <a:rPr lang="en-US" sz="1700" b="1" dirty="0">
                 <a:solidFill>
                   <a:srgbClr val="E6EDF3"/>
                 </a:solidFill>
@@ -8094,9 +8094,9 @@
                 <a:ea typeface="Cambria" pitchFamily="34" charset="-122"/>
                 <a:cs typeface="Cambria" pitchFamily="34" charset="-120"/>
               </a:rPr>
-              <a:t>Uji data asli</a:t>
-            </a:r>
-            <a:endParaRPr lang="en-US" sz="1800" dirty="0"/>
+              <a:t>5-fold GroupKFold</a:t>
+            </a:r>
+            <a:endParaRPr lang="en-US" sz="1700" dirty="0"/>
           </a:p>
         </p:txBody>
       </p:sp>
@@ -8108,8 +8108,8 @@
         </p:nvSpPr>
         <p:spPr>
           <a:xfrm>
-            <a:off x="6391656" y="3429000"/>
-            <a:ext cx="2167128" cy="1143000"/>
+            <a:off x="5276088" y="3337560"/>
+            <a:ext cx="1645920" cy="1325880"/>
           </a:xfrm>
           <a:prstGeom prst="rect">
             <a:avLst/>
@@ -8128,7 +8128,7 @@
               <a:buNone/>
             </a:pPr>
             <a:r>
-              <a:rPr lang="en-US" sz="1500" dirty="0">
+              <a:rPr lang="en-US" sz="1400" dirty="0">
                 <a:solidFill>
                   <a:srgbClr val="A9B4C2"/>
                 </a:solidFill>
@@ -8136,9 +8136,9 @@
                 <a:ea typeface="Calibri" pitchFamily="34" charset="-122"/>
                 <a:cs typeface="Calibri" pitchFamily="34" charset="-120"/>
               </a:rPr>
-              <a:t>Model diuji di 2 akun asli yang tidak pernah dilihat saat latih.</a:t>
-            </a:r>
-            <a:endParaRPr lang="en-US" sz="1500" dirty="0"/>
+              <a:t>Rata-rata ± simpangan baku, lalu uji t berpasangan terkoreksi.</a:t>
+            </a:r>
+            <a:endParaRPr lang="en-US" sz="1400" dirty="0"/>
           </a:p>
         </p:txBody>
       </p:sp>
@@ -8150,12 +8150,12 @@
         </p:nvSpPr>
         <p:spPr>
           <a:xfrm>
-            <a:off x="8970264" y="1828800"/>
-            <a:ext cx="2624328" cy="2926080"/>
+            <a:off x="7296912" y="1737360"/>
+            <a:ext cx="2103120" cy="3108960"/>
           </a:xfrm>
           <a:prstGeom prst="roundRect">
             <a:avLst>
-              <a:gd name="adj" fmla="val 2787"/>
+              <a:gd name="adj" fmla="val 3478"/>
             </a:avLst>
           </a:prstGeom>
           <a:solidFill>
@@ -8177,14 +8177,14 @@
         </p:nvSpPr>
         <p:spPr>
           <a:xfrm>
-            <a:off x="9198864" y="2057400"/>
+            <a:off x="7525512" y="1965960"/>
             <a:ext cx="457200" cy="457200"/>
           </a:xfrm>
           <a:prstGeom prst="ellipse">
             <a:avLst/>
           </a:prstGeom>
           <a:solidFill>
-            <a:srgbClr val="BC8CFF"/>
+            <a:srgbClr val="3FB950"/>
           </a:solidFill>
           <a:ln/>
         </p:spPr>
@@ -8197,7 +8197,7 @@
         </p:nvSpPr>
         <p:spPr>
           <a:xfrm>
-            <a:off x="9198864" y="2057400"/>
+            <a:off x="7525512" y="1965960"/>
             <a:ext cx="457200" cy="457200"/>
           </a:xfrm>
           <a:prstGeom prst="rect">
@@ -8236,8 +8236,8 @@
         </p:nvSpPr>
         <p:spPr>
           <a:xfrm>
-            <a:off x="9198864" y="2651760"/>
-            <a:ext cx="2167128" cy="731520"/>
+            <a:off x="7525512" y="2560320"/>
+            <a:ext cx="1645920" cy="731520"/>
           </a:xfrm>
           <a:prstGeom prst="rect">
             <a:avLst/>
@@ -8253,7 +8253,7 @@
               <a:buNone/>
             </a:pPr>
             <a:r>
-              <a:rPr lang="en-US" sz="1800" b="1" dirty="0">
+              <a:rPr lang="en-US" sz="1700" b="1" dirty="0">
                 <a:solidFill>
                   <a:srgbClr val="E6EDF3"/>
                 </a:solidFill>
@@ -8261,9 +8261,9 @@
                 <a:ea typeface="Cambria" pitchFamily="34" charset="-122"/>
                 <a:cs typeface="Cambria" pitchFamily="34" charset="-120"/>
               </a:rPr>
-              <a:t>Latih di data asli</a:t>
-            </a:r>
-            <a:endParaRPr lang="en-US" sz="1800" dirty="0"/>
+              <a:t>Uji data asli</a:t>
+            </a:r>
+            <a:endParaRPr lang="en-US" sz="1700" dirty="0"/>
           </a:p>
         </p:txBody>
       </p:sp>
@@ -8275,8 +8275,8 @@
         </p:nvSpPr>
         <p:spPr>
           <a:xfrm>
-            <a:off x="9198864" y="3429000"/>
-            <a:ext cx="2167128" cy="1143000"/>
+            <a:off x="7525512" y="3337560"/>
+            <a:ext cx="1645920" cy="1325880"/>
           </a:xfrm>
           <a:prstGeom prst="rect">
             <a:avLst/>
@@ -8295,7 +8295,7 @@
               <a:buNone/>
             </a:pPr>
             <a:r>
-              <a:rPr lang="en-US" sz="1500" dirty="0">
+              <a:rPr lang="en-US" sz="1400" dirty="0">
                 <a:solidFill>
                   <a:srgbClr val="A9B4C2"/>
                 </a:solidFill>
@@ -8303,15 +8303,182 @@
                 <a:ea typeface="Calibri" pitchFamily="34" charset="-122"/>
                 <a:cs typeface="Calibri" pitchFamily="34" charset="-120"/>
               </a:rPr>
-              <a:t>Eksperimen kedua: latih + uji hanya data asli, 5-fold per siklus pity.</a:t>
-            </a:r>
-            <a:endParaRPr lang="en-US" sz="1500" dirty="0"/>
-          </a:p>
-        </p:txBody>
-      </p:sp>
-      <p:sp>
-        <p:nvSpPr>
-          <p:cNvPr id="26" name="Text 24"/>
+              <a:t>Model diuji di 2 akun asli yang tidak pernah dilihat saat latih.</a:t>
+            </a:r>
+            <a:endParaRPr lang="en-US" sz="1400" dirty="0"/>
+          </a:p>
+        </p:txBody>
+      </p:sp>
+      <p:sp>
+        <p:nvSpPr>
+          <p:cNvPr id="26" name="Shape 24"/>
+          <p:cNvSpPr/>
+          <p:nvPr/>
+        </p:nvSpPr>
+        <p:spPr>
+          <a:xfrm>
+            <a:off x="9546336" y="1737360"/>
+            <a:ext cx="2103120" cy="3108960"/>
+          </a:xfrm>
+          <a:prstGeom prst="roundRect">
+            <a:avLst>
+              <a:gd name="adj" fmla="val 3478"/>
+            </a:avLst>
+          </a:prstGeom>
+          <a:solidFill>
+            <a:srgbClr val="1C2230"/>
+          </a:solidFill>
+          <a:ln w="9525">
+            <a:solidFill>
+              <a:srgbClr val="30363D"/>
+            </a:solidFill>
+            <a:prstDash val="solid"/>
+          </a:ln>
+        </p:spPr>
+      </p:sp>
+      <p:sp>
+        <p:nvSpPr>
+          <p:cNvPr id="27" name="Shape 25"/>
+          <p:cNvSpPr/>
+          <p:nvPr/>
+        </p:nvSpPr>
+        <p:spPr>
+          <a:xfrm>
+            <a:off x="9774936" y="1965960"/>
+            <a:ext cx="457200" cy="457200"/>
+          </a:xfrm>
+          <a:prstGeom prst="ellipse">
+            <a:avLst/>
+          </a:prstGeom>
+          <a:solidFill>
+            <a:srgbClr val="BC8CFF"/>
+          </a:solidFill>
+          <a:ln/>
+        </p:spPr>
+      </p:sp>
+      <p:sp>
+        <p:nvSpPr>
+          <p:cNvPr id="28" name="Text 26"/>
+          <p:cNvSpPr txBox="1"/>
+          <p:nvPr/>
+        </p:nvSpPr>
+        <p:spPr>
+          <a:xfrm>
+            <a:off x="9774936" y="1965960"/>
+            <a:ext cx="457200" cy="457200"/>
+          </a:xfrm>
+          <a:prstGeom prst="rect">
+            <a:avLst/>
+          </a:prstGeom>
+          <a:noFill/>
+          <a:ln/>
+        </p:spPr>
+        <p:txBody>
+          <a:bodyPr wrap="square" lIns="0" tIns="0" rIns="0" bIns="0" rtlCol="0" anchor="ctr"/>
+          <a:lstStyle/>
+          <a:p>
+            <a:pPr algn="ctr" indent="0" marL="0">
+              <a:buNone/>
+            </a:pPr>
+            <a:r>
+              <a:rPr lang="en-US" sz="1600" b="1" dirty="0">
+                <a:solidFill>
+                  <a:srgbClr val="0E1117"/>
+                </a:solidFill>
+                <a:latin typeface="Calibri" pitchFamily="34" charset="0"/>
+                <a:ea typeface="Calibri" pitchFamily="34" charset="-122"/>
+                <a:cs typeface="Calibri" pitchFamily="34" charset="-120"/>
+              </a:rPr>
+              <a:t>5</a:t>
+            </a:r>
+            <a:endParaRPr lang="en-US" sz="1600" dirty="0"/>
+          </a:p>
+        </p:txBody>
+      </p:sp>
+      <p:sp>
+        <p:nvSpPr>
+          <p:cNvPr id="29" name="Text 27"/>
+          <p:cNvSpPr txBox="1"/>
+          <p:nvPr/>
+        </p:nvSpPr>
+        <p:spPr>
+          <a:xfrm>
+            <a:off x="9774936" y="2560320"/>
+            <a:ext cx="1645920" cy="731520"/>
+          </a:xfrm>
+          <a:prstGeom prst="rect">
+            <a:avLst/>
+          </a:prstGeom>
+          <a:noFill/>
+          <a:ln/>
+        </p:spPr>
+        <p:txBody>
+          <a:bodyPr wrap="square" lIns="0" tIns="0" rIns="0" bIns="0" rtlCol="0" anchor="t"/>
+          <a:lstStyle/>
+          <a:p>
+            <a:pPr indent="0" marL="0">
+              <a:buNone/>
+            </a:pPr>
+            <a:r>
+              <a:rPr lang="en-US" sz="1700" b="1" dirty="0">
+                <a:solidFill>
+                  <a:srgbClr val="E6EDF3"/>
+                </a:solidFill>
+                <a:latin typeface="Cambria" pitchFamily="34" charset="0"/>
+                <a:ea typeface="Cambria" pitchFamily="34" charset="-122"/>
+                <a:cs typeface="Cambria" pitchFamily="34" charset="-120"/>
+              </a:rPr>
+              <a:t>Latih di data asli</a:t>
+            </a:r>
+            <a:endParaRPr lang="en-US" sz="1700" dirty="0"/>
+          </a:p>
+        </p:txBody>
+      </p:sp>
+      <p:sp>
+        <p:nvSpPr>
+          <p:cNvPr id="30" name="Text 28"/>
+          <p:cNvSpPr txBox="1"/>
+          <p:nvPr/>
+        </p:nvSpPr>
+        <p:spPr>
+          <a:xfrm>
+            <a:off x="9774936" y="3337560"/>
+            <a:ext cx="1645920" cy="1325880"/>
+          </a:xfrm>
+          <a:prstGeom prst="rect">
+            <a:avLst/>
+          </a:prstGeom>
+          <a:noFill/>
+          <a:ln/>
+        </p:spPr>
+        <p:txBody>
+          <a:bodyPr wrap="square" lIns="0" tIns="0" rIns="0" bIns="0" rtlCol="0" anchor="t"/>
+          <a:lstStyle/>
+          <a:p>
+            <a:pPr indent="0" marL="0">
+              <a:spcAft>
+                <a:spcPts val="400"/>
+              </a:spcAft>
+              <a:buNone/>
+            </a:pPr>
+            <a:r>
+              <a:rPr lang="en-US" sz="1400" dirty="0">
+                <a:solidFill>
+                  <a:srgbClr val="A9B4C2"/>
+                </a:solidFill>
+                <a:latin typeface="Calibri" pitchFamily="34" charset="0"/>
+                <a:ea typeface="Calibri" pitchFamily="34" charset="-122"/>
+                <a:cs typeface="Calibri" pitchFamily="34" charset="-120"/>
+              </a:rPr>
+              <a:t>Latih + uji hanya data asli, 5-fold per siklus pity, nested grid search.</a:t>
+            </a:r>
+            <a:endParaRPr lang="en-US" sz="1400" dirty="0"/>
+          </a:p>
+        </p:txBody>
+      </p:sp>
+      <p:sp>
+        <p:nvSpPr>
+          <p:cNvPr id="31" name="Text 29"/>
           <p:cNvSpPr txBox="1"/>
           <p:nvPr/>
         </p:nvSpPr>
@@ -18709,12 +18876,12 @@
         </p:nvSpPr>
         <p:spPr>
           <a:xfrm>
-            <a:off x="548640" y="1645920"/>
-            <a:ext cx="3566160" cy="2057400"/>
+            <a:off x="548640" y="1554480"/>
+            <a:ext cx="3566160" cy="1828800"/>
           </a:xfrm>
           <a:prstGeom prst="roundRect">
             <a:avLst>
-              <a:gd name="adj" fmla="val 3556"/>
+              <a:gd name="adj" fmla="val 4000"/>
             </a:avLst>
           </a:prstGeom>
           <a:solidFill>
@@ -18736,7 +18903,7 @@
         </p:nvSpPr>
         <p:spPr>
           <a:xfrm>
-            <a:off x="777240" y="1874520"/>
+            <a:off x="777240" y="1783080"/>
             <a:ext cx="3108960" cy="411480"/>
           </a:xfrm>
           <a:prstGeom prst="rect">
@@ -18775,8 +18942,8 @@
         </p:nvSpPr>
         <p:spPr>
           <a:xfrm>
-            <a:off x="777240" y="2331720"/>
-            <a:ext cx="3108960" cy="1188720"/>
+            <a:off x="777240" y="2240280"/>
+            <a:ext cx="3108960" cy="960120"/>
           </a:xfrm>
           <a:prstGeom prst="rect">
             <a:avLst/>
@@ -18817,12 +18984,12 @@
         </p:nvSpPr>
         <p:spPr>
           <a:xfrm>
-            <a:off x="4297680" y="1645920"/>
-            <a:ext cx="3566160" cy="2057400"/>
+            <a:off x="4297680" y="1554480"/>
+            <a:ext cx="3566160" cy="1828800"/>
           </a:xfrm>
           <a:prstGeom prst="roundRect">
             <a:avLst>
-              <a:gd name="adj" fmla="val 3556"/>
+              <a:gd name="adj" fmla="val 4000"/>
             </a:avLst>
           </a:prstGeom>
           <a:solidFill>
@@ -18844,7 +19011,7 @@
         </p:nvSpPr>
         <p:spPr>
           <a:xfrm>
-            <a:off x="4526280" y="1874520"/>
+            <a:off x="4526280" y="1783080"/>
             <a:ext cx="3108960" cy="411480"/>
           </a:xfrm>
           <a:prstGeom prst="rect">
@@ -18883,8 +19050,8 @@
         </p:nvSpPr>
         <p:spPr>
           <a:xfrm>
-            <a:off x="4526280" y="2331720"/>
-            <a:ext cx="3108960" cy="1188720"/>
+            <a:off x="4526280" y="2240280"/>
+            <a:ext cx="3108960" cy="960120"/>
           </a:xfrm>
           <a:prstGeom prst="rect">
             <a:avLst/>
@@ -18911,7 +19078,7 @@
                 <a:ea typeface="Calibri" pitchFamily="34" charset="-122"/>
                 <a:cs typeface="Calibri" pitchFamily="34" charset="-120"/>
               </a:rPr>
-              <a:t>Menebak dari 101 data latih terdekat (fitur dinormalisasi).</a:t>
+              <a:t>Menebak dari k data latih terdekat (fitur dinormalisasi).</a:t>
             </a:r>
             <a:endParaRPr lang="en-US" sz="1500" dirty="0"/>
           </a:p>
@@ -18925,12 +19092,12 @@
         </p:nvSpPr>
         <p:spPr>
           <a:xfrm>
-            <a:off x="8046720" y="1645920"/>
-            <a:ext cx="3566160" cy="2057400"/>
+            <a:off x="8046720" y="1554480"/>
+            <a:ext cx="3566160" cy="1828800"/>
           </a:xfrm>
           <a:prstGeom prst="roundRect">
             <a:avLst>
-              <a:gd name="adj" fmla="val 3556"/>
+              <a:gd name="adj" fmla="val 4000"/>
             </a:avLst>
           </a:prstGeom>
           <a:solidFill>
@@ -18952,7 +19119,7 @@
         </p:nvSpPr>
         <p:spPr>
           <a:xfrm>
-            <a:off x="8275320" y="1874520"/>
+            <a:off x="8275320" y="1783080"/>
             <a:ext cx="3108960" cy="411480"/>
           </a:xfrm>
           <a:prstGeom prst="rect">
@@ -18991,8 +19158,8 @@
         </p:nvSpPr>
         <p:spPr>
           <a:xfrm>
-            <a:off x="8275320" y="2331720"/>
-            <a:ext cx="3108960" cy="1188720"/>
+            <a:off x="8275320" y="2240280"/>
+            <a:ext cx="3108960" cy="960120"/>
           </a:xfrm>
           <a:prstGeom prst="rect">
             <a:avLst/>
@@ -19033,12 +19200,12 @@
         </p:nvSpPr>
         <p:spPr>
           <a:xfrm>
-            <a:off x="548640" y="3886200"/>
-            <a:ext cx="3566160" cy="2057400"/>
+            <a:off x="548640" y="3566160"/>
+            <a:ext cx="3566160" cy="1828800"/>
           </a:xfrm>
           <a:prstGeom prst="roundRect">
             <a:avLst>
-              <a:gd name="adj" fmla="val 3556"/>
+              <a:gd name="adj" fmla="val 4000"/>
             </a:avLst>
           </a:prstGeom>
           <a:solidFill>
@@ -19060,7 +19227,7 @@
         </p:nvSpPr>
         <p:spPr>
           <a:xfrm>
-            <a:off x="777240" y="4114800"/>
+            <a:off x="777240" y="3794760"/>
             <a:ext cx="3108960" cy="411480"/>
           </a:xfrm>
           <a:prstGeom prst="rect">
@@ -19099,8 +19266,8 @@
         </p:nvSpPr>
         <p:spPr>
           <a:xfrm>
-            <a:off x="777240" y="4572000"/>
-            <a:ext cx="3108960" cy="1188720"/>
+            <a:off x="777240" y="4251960"/>
+            <a:ext cx="3108960" cy="960120"/>
           </a:xfrm>
           <a:prstGeom prst="rect">
             <a:avLst/>
@@ -19127,7 +19294,7 @@
                 <a:ea typeface="Calibri" pitchFamily="34" charset="-122"/>
                 <a:cs typeface="Calibri" pitchFamily="34" charset="-120"/>
               </a:rPr>
-              <a:t>Aturan jika–maka yang mudah dibaca (max depth 6).</a:t>
+              <a:t>Aturan jika–maka yang mudah dibaca manusia.</a:t>
             </a:r>
             <a:endParaRPr lang="en-US" sz="1500" dirty="0"/>
           </a:p>
@@ -19141,12 +19308,12 @@
         </p:nvSpPr>
         <p:spPr>
           <a:xfrm>
-            <a:off x="4297680" y="3886200"/>
-            <a:ext cx="3566160" cy="2057400"/>
+            <a:off x="4297680" y="3566160"/>
+            <a:ext cx="3566160" cy="1828800"/>
           </a:xfrm>
           <a:prstGeom prst="roundRect">
             <a:avLst>
-              <a:gd name="adj" fmla="val 3556"/>
+              <a:gd name="adj" fmla="val 4000"/>
             </a:avLst>
           </a:prstGeom>
           <a:solidFill>
@@ -19168,7 +19335,7 @@
         </p:nvSpPr>
         <p:spPr>
           <a:xfrm>
-            <a:off x="4526280" y="4114800"/>
+            <a:off x="4526280" y="3794760"/>
             <a:ext cx="3108960" cy="411480"/>
           </a:xfrm>
           <a:prstGeom prst="rect">
@@ -19207,8 +19374,8 @@
         </p:nvSpPr>
         <p:spPr>
           <a:xfrm>
-            <a:off x="4526280" y="4572000"/>
-            <a:ext cx="3108960" cy="1188720"/>
+            <a:off x="4526280" y="4251960"/>
+            <a:ext cx="3108960" cy="960120"/>
           </a:xfrm>
           <a:prstGeom prst="rect">
             <a:avLst/>
@@ -19249,12 +19416,12 @@
         </p:nvSpPr>
         <p:spPr>
           <a:xfrm>
-            <a:off x="8046720" y="3886200"/>
-            <a:ext cx="3566160" cy="2057400"/>
+            <a:off x="8046720" y="3566160"/>
+            <a:ext cx="3566160" cy="1828800"/>
           </a:xfrm>
           <a:prstGeom prst="roundRect">
             <a:avLst>
-              <a:gd name="adj" fmla="val 3556"/>
+              <a:gd name="adj" fmla="val 4000"/>
             </a:avLst>
           </a:prstGeom>
           <a:solidFill>
@@ -19276,7 +19443,7 @@
         </p:nvSpPr>
         <p:spPr>
           <a:xfrm>
-            <a:off x="8275320" y="4114800"/>
+            <a:off x="8275320" y="3794760"/>
             <a:ext cx="3108960" cy="411480"/>
           </a:xfrm>
           <a:prstGeom prst="rect">
@@ -19315,8 +19482,8 @@
         </p:nvSpPr>
         <p:spPr>
           <a:xfrm>
-            <a:off x="8275320" y="4572000"/>
-            <a:ext cx="3108960" cy="1188720"/>
+            <a:off x="8275320" y="4251960"/>
+            <a:ext cx="3108960" cy="960120"/>
           </a:xfrm>
           <a:prstGeom prst="rect">
             <a:avLst/>
@@ -19344,6 +19511,45 @@
                 <a:cs typeface="Calibri" pitchFamily="34" charset="-120"/>
               </a:rPr>
               <a:t>300 pohon berurutan memperbaiki kesalahan (boosting).</a:t>
+            </a:r>
+            <a:endParaRPr lang="en-US" sz="1500" dirty="0"/>
+          </a:p>
+        </p:txBody>
+      </p:sp>
+      <p:sp>
+        <p:nvSpPr>
+          <p:cNvPr id="24" name="Text 22"/>
+          <p:cNvSpPr txBox="1"/>
+          <p:nvPr/>
+        </p:nvSpPr>
+        <p:spPr>
+          <a:xfrm>
+            <a:off x="548640" y="5669280"/>
+            <a:ext cx="11064240" cy="457200"/>
+          </a:xfrm>
+          <a:prstGeom prst="rect">
+            <a:avLst/>
+          </a:prstGeom>
+          <a:noFill/>
+          <a:ln/>
+        </p:spPr>
+        <p:txBody>
+          <a:bodyPr wrap="square" lIns="0" tIns="0" rIns="0" bIns="0" rtlCol="0" anchor="ctr"/>
+          <a:lstStyle/>
+          <a:p>
+            <a:pPr indent="0" marL="0">
+              <a:buNone/>
+            </a:pPr>
+            <a:r>
+              <a:rPr lang="en-US" sz="1500" dirty="0">
+                <a:solidFill>
+                  <a:srgbClr val="A9B4C2"/>
+                </a:solidFill>
+                <a:latin typeface="Calibri" pitchFamily="34" charset="0"/>
+                <a:ea typeface="Calibri" pitchFamily="34" charset="-122"/>
+                <a:cs typeface="Calibri" pitchFamily="34" charset="-120"/>
+              </a:rPr>
+              <a:t>Hyperparameter (k, var_smoothing, C, kedalaman pohon, learning rate) dipilih dengan grid search, bukan ditebak.</a:t>
             </a:r>
             <a:endParaRPr lang="en-US" sz="1500" dirty="0"/>
           </a:p>

</xml_diff>

<commit_message>
Buat proposal UTS hitam-putih dengan bahasa yang lebih sederhana
Diagram peta jalan dan alur metode digambar ulang hitam-putih dengan huruf
serif, tabel tanpa warna, dan tangkapan layar aplikasi dihapus. Telaah
pustaka, eksperimen, dan pra-pemrosesan ditulis sebagai paragraf biasa,
tanpa huruf tebal di tengah kalimat.
</commit_message>
<xml_diff>
--- a/docs/tugas/UTS_Slide_Kelompok6_A11.4502.pptx
+++ b/docs/tugas/UTS_Slide_Kelompok6_A11.4502.pptx
@@ -10347,8 +10347,8 @@
         </p:nvSpPr>
         <p:spPr>
           <a:xfrm>
-            <a:off x="1773936" y="1444752"/>
-            <a:ext cx="8613648" cy="4882896"/>
+            <a:off x="590140" y="1444752"/>
+            <a:ext cx="10981241" cy="4882896"/>
           </a:xfrm>
           <a:prstGeom prst="roundRect">
             <a:avLst>
@@ -10382,8 +10382,8 @@
         </p:blipFill>
         <p:spPr>
           <a:xfrm>
-            <a:off x="1883664" y="1554480"/>
-            <a:ext cx="8394192" cy="4663440"/>
+            <a:off x="699868" y="1554480"/>
+            <a:ext cx="10761785" cy="4663440"/>
           </a:xfrm>
           <a:prstGeom prst="rect">
             <a:avLst/>

</xml_diff>